<commit_message>
minor fixes in the ppt after claude discussion
</commit_message>
<xml_diff>
--- a/Complaint_Log_Analysis_Slides.pptx
+++ b/Complaint_Log_Analysis_Slides.pptx
@@ -1587,7 +1587,7 @@
           <a:p>
             <a:fld id="{0E044B61-B5F1-4E54-8FE3-9F387B431724}" type="datetimeFigureOut">
               <a:rPr lang="en-IN" smtClean="0"/>
-              <a:t>28-06-2026</a:t>
+              <a:t>30-06-2026</a:t>
             </a:fld>
             <a:endParaRPr lang="en-IN"/>
           </a:p>
@@ -1787,7 +1787,7 @@
           <a:p>
             <a:fld id="{0E044B61-B5F1-4E54-8FE3-9F387B431724}" type="datetimeFigureOut">
               <a:rPr lang="en-IN" smtClean="0"/>
-              <a:t>28-06-2026</a:t>
+              <a:t>30-06-2026</a:t>
             </a:fld>
             <a:endParaRPr lang="en-IN"/>
           </a:p>
@@ -1997,7 +1997,7 @@
           <a:p>
             <a:fld id="{0E044B61-B5F1-4E54-8FE3-9F387B431724}" type="datetimeFigureOut">
               <a:rPr lang="en-IN" smtClean="0"/>
-              <a:t>28-06-2026</a:t>
+              <a:t>30-06-2026</a:t>
             </a:fld>
             <a:endParaRPr lang="en-IN"/>
           </a:p>
@@ -2197,7 +2197,7 @@
           <a:p>
             <a:fld id="{0E044B61-B5F1-4E54-8FE3-9F387B431724}" type="datetimeFigureOut">
               <a:rPr lang="en-IN" smtClean="0"/>
-              <a:t>28-06-2026</a:t>
+              <a:t>30-06-2026</a:t>
             </a:fld>
             <a:endParaRPr lang="en-IN"/>
           </a:p>
@@ -2473,7 +2473,7 @@
           <a:p>
             <a:fld id="{0E044B61-B5F1-4E54-8FE3-9F387B431724}" type="datetimeFigureOut">
               <a:rPr lang="en-IN" smtClean="0"/>
-              <a:t>28-06-2026</a:t>
+              <a:t>30-06-2026</a:t>
             </a:fld>
             <a:endParaRPr lang="en-IN"/>
           </a:p>
@@ -2741,7 +2741,7 @@
           <a:p>
             <a:fld id="{0E044B61-B5F1-4E54-8FE3-9F387B431724}" type="datetimeFigureOut">
               <a:rPr lang="en-IN" smtClean="0"/>
-              <a:t>28-06-2026</a:t>
+              <a:t>30-06-2026</a:t>
             </a:fld>
             <a:endParaRPr lang="en-IN"/>
           </a:p>
@@ -3156,7 +3156,7 @@
           <a:p>
             <a:fld id="{0E044B61-B5F1-4E54-8FE3-9F387B431724}" type="datetimeFigureOut">
               <a:rPr lang="en-IN" smtClean="0"/>
-              <a:t>28-06-2026</a:t>
+              <a:t>30-06-2026</a:t>
             </a:fld>
             <a:endParaRPr lang="en-IN"/>
           </a:p>
@@ -3298,7 +3298,7 @@
           <a:p>
             <a:fld id="{0E044B61-B5F1-4E54-8FE3-9F387B431724}" type="datetimeFigureOut">
               <a:rPr lang="en-IN" smtClean="0"/>
-              <a:t>28-06-2026</a:t>
+              <a:t>30-06-2026</a:t>
             </a:fld>
             <a:endParaRPr lang="en-IN"/>
           </a:p>
@@ -3411,7 +3411,7 @@
           <a:p>
             <a:fld id="{0E044B61-B5F1-4E54-8FE3-9F387B431724}" type="datetimeFigureOut">
               <a:rPr lang="en-IN" smtClean="0"/>
-              <a:t>28-06-2026</a:t>
+              <a:t>30-06-2026</a:t>
             </a:fld>
             <a:endParaRPr lang="en-IN"/>
           </a:p>
@@ -3724,7 +3724,7 @@
           <a:p>
             <a:fld id="{0E044B61-B5F1-4E54-8FE3-9F387B431724}" type="datetimeFigureOut">
               <a:rPr lang="en-IN" smtClean="0"/>
-              <a:t>28-06-2026</a:t>
+              <a:t>30-06-2026</a:t>
             </a:fld>
             <a:endParaRPr lang="en-IN"/>
           </a:p>
@@ -4013,7 +4013,7 @@
           <a:p>
             <a:fld id="{0E044B61-B5F1-4E54-8FE3-9F387B431724}" type="datetimeFigureOut">
               <a:rPr lang="en-IN" smtClean="0"/>
-              <a:t>28-06-2026</a:t>
+              <a:t>30-06-2026</a:t>
             </a:fld>
             <a:endParaRPr lang="en-IN"/>
           </a:p>
@@ -4256,7 +4256,7 @@
           <a:p>
             <a:fld id="{0E044B61-B5F1-4E54-8FE3-9F387B431724}" type="datetimeFigureOut">
               <a:rPr lang="en-IN" smtClean="0"/>
-              <a:t>28-06-2026</a:t>
+              <a:t>30-06-2026</a:t>
             </a:fld>
             <a:endParaRPr lang="en-IN"/>
           </a:p>
@@ -6047,6 +6047,90 @@
           </a:p>
         </p:txBody>
       </p:sp>
+      <p:sp>
+        <p:nvSpPr>
+          <p:cNvPr id="7" name="TextBox 6">
+            <a:extLst>
+              <a:ext uri="{FF2B5EF4-FFF2-40B4-BE49-F238E27FC236}">
+                <a16:creationId xmlns:a16="http://schemas.microsoft.com/office/drawing/2014/main" id="{1784B61D-CB81-9932-CBFD-4D20F0D5A397}"/>
+              </a:ext>
+            </a:extLst>
+          </p:cNvPr>
+          <p:cNvSpPr txBox="1"/>
+          <p:nvPr/>
+        </p:nvSpPr>
+        <p:spPr>
+          <a:xfrm>
+            <a:off x="6096000" y="5815410"/>
+            <a:ext cx="957834" cy="261610"/>
+          </a:xfrm>
+          <a:prstGeom prst="rect">
+            <a:avLst/>
+          </a:prstGeom>
+          <a:noFill/>
+        </p:spPr>
+        <p:txBody>
+          <a:bodyPr wrap="square">
+            <a:spAutoFit/>
+          </a:bodyPr>
+          <a:lstStyle/>
+          <a:p>
+            <a:r>
+              <a:rPr lang="en-IN" sz="1100" dirty="0">
+                <a:solidFill>
+                  <a:schemeClr val="bg1">
+                    <a:lumMod val="65000"/>
+                  </a:schemeClr>
+                </a:solidFill>
+                <a:latin typeface="Bahnschrift Light" panose="020B0502040204020203" pitchFamily="34" charset="0"/>
+              </a:rPr>
+              <a:t>[8/24 = 0.33] </a:t>
+            </a:r>
+          </a:p>
+        </p:txBody>
+      </p:sp>
+      <p:sp>
+        <p:nvSpPr>
+          <p:cNvPr id="8" name="TextBox 7">
+            <a:extLst>
+              <a:ext uri="{FF2B5EF4-FFF2-40B4-BE49-F238E27FC236}">
+                <a16:creationId xmlns:a16="http://schemas.microsoft.com/office/drawing/2014/main" id="{815A5546-50B2-5E89-35EB-C4EA16BA2768}"/>
+              </a:ext>
+            </a:extLst>
+          </p:cNvPr>
+          <p:cNvSpPr txBox="1"/>
+          <p:nvPr/>
+        </p:nvSpPr>
+        <p:spPr>
+          <a:xfrm>
+            <a:off x="8790432" y="6295078"/>
+            <a:ext cx="1057656" cy="270313"/>
+          </a:xfrm>
+          <a:prstGeom prst="rect">
+            <a:avLst/>
+          </a:prstGeom>
+          <a:noFill/>
+        </p:spPr>
+        <p:txBody>
+          <a:bodyPr wrap="square">
+            <a:spAutoFit/>
+          </a:bodyPr>
+          <a:lstStyle/>
+          <a:p>
+            <a:r>
+              <a:rPr lang="en-IN" sz="1100" dirty="0">
+                <a:solidFill>
+                  <a:schemeClr val="bg1">
+                    <a:lumMod val="65000"/>
+                  </a:schemeClr>
+                </a:solidFill>
+                <a:latin typeface="Bahnschrift Light" panose="020B0502040204020203" pitchFamily="34" charset="0"/>
+              </a:rPr>
+              <a:t>[8/121 = 0.066] </a:t>
+            </a:r>
+          </a:p>
+        </p:txBody>
+      </p:sp>
     </p:spTree>
     <p:extLst>
       <p:ext uri="{BB962C8B-B14F-4D97-AF65-F5344CB8AC3E}">
@@ -6456,7 +6540,7 @@
         </p:nvSpPr>
         <p:spPr>
           <a:xfrm>
-            <a:off x="8063913" y="4889443"/>
+            <a:off x="8063913" y="4784999"/>
             <a:ext cx="3727574" cy="954107"/>
           </a:xfrm>
           <a:prstGeom prst="rect">
@@ -6585,8 +6669,8 @@
         </p:blipFill>
         <p:spPr>
           <a:xfrm>
-            <a:off x="759256" y="2044006"/>
-            <a:ext cx="5982218" cy="3731872"/>
+            <a:off x="759256" y="1998285"/>
+            <a:ext cx="5982218" cy="3823314"/>
           </a:xfrm>
           <a:prstGeom prst="rect">
             <a:avLst/>
@@ -6710,7 +6794,7 @@
         </p:nvSpPr>
         <p:spPr>
           <a:xfrm>
-            <a:off x="7175650" y="2044005"/>
+            <a:off x="7175650" y="1998285"/>
             <a:ext cx="4691671" cy="1169551"/>
           </a:xfrm>
           <a:prstGeom prst="rect">
@@ -6808,8 +6892,8 @@
         </p:nvSpPr>
         <p:spPr>
           <a:xfrm>
-            <a:off x="7175648" y="3314532"/>
-            <a:ext cx="4902052" cy="1815882"/>
+            <a:off x="7175648" y="3268812"/>
+            <a:ext cx="4902052" cy="2031325"/>
           </a:xfrm>
           <a:prstGeom prst="rect">
             <a:avLst/>
@@ -6828,20 +6912,21 @@
                 <a:ea typeface="Microsoft Sans Serif" panose="020B0604020202020204" pitchFamily="34" charset="0"/>
                 <a:cs typeface="Microsoft Sans Serif" panose="020B0604020202020204" pitchFamily="34" charset="0"/>
               </a:rPr>
-              <a:t>BBMP's</a:t>
+              <a:t>BBMP </a:t>
             </a:r>
             <a:r>
               <a:rPr lang="en-US" sz="1400" dirty="0">
                 <a:solidFill>
-                  <a:schemeClr val="bg1">
+                  <a:schemeClr val="tx1">
                     <a:lumMod val="50000"/>
+                    <a:lumOff val="50000"/>
                   </a:schemeClr>
                 </a:solidFill>
                 <a:latin typeface="Bahnschrift Light" panose="020B0502040204020203" pitchFamily="34" charset="0"/>
                 <a:ea typeface="Microsoft Sans Serif" panose="020B0604020202020204" pitchFamily="34" charset="0"/>
                 <a:cs typeface="Microsoft Sans Serif" panose="020B0604020202020204" pitchFamily="34" charset="0"/>
               </a:rPr>
-              <a:t> dominance is expected. As the primary municipal body, it handles the widest range of complaint categories and the highest complaint volume, yet maintains a 70% effective resolution rate. In contrast, </a:t>
+              <a:t>covers over </a:t>
             </a:r>
             <a:r>
               <a:rPr lang="en-US" sz="1400" dirty="0">
@@ -6849,20 +6934,21 @@
                 <a:ea typeface="Microsoft Sans Serif" panose="020B0604020202020204" pitchFamily="34" charset="0"/>
                 <a:cs typeface="Microsoft Sans Serif" panose="020B0604020202020204" pitchFamily="34" charset="0"/>
               </a:rPr>
-              <a:t>BTC </a:t>
+              <a:t>13000 complaints </a:t>
             </a:r>
             <a:r>
               <a:rPr lang="en-US" sz="1400" dirty="0">
                 <a:solidFill>
-                  <a:schemeClr val="bg2">
+                  <a:schemeClr val="tx1">
                     <a:lumMod val="50000"/>
+                    <a:lumOff val="50000"/>
                   </a:schemeClr>
                 </a:solidFill>
                 <a:latin typeface="Bahnschrift Light" panose="020B0502040204020203" pitchFamily="34" charset="0"/>
                 <a:ea typeface="Microsoft Sans Serif" panose="020B0604020202020204" pitchFamily="34" charset="0"/>
                 <a:cs typeface="Microsoft Sans Serif" panose="020B0604020202020204" pitchFamily="34" charset="0"/>
               </a:rPr>
-              <a:t>has a </a:t>
+              <a:t>and its </a:t>
             </a:r>
             <a:r>
               <a:rPr lang="en-US" sz="1400" dirty="0">
@@ -6875,6 +6961,40 @@
                 <a:ea typeface="Microsoft Sans Serif" panose="020B0604020202020204" pitchFamily="34" charset="0"/>
                 <a:cs typeface="Microsoft Sans Serif" panose="020B0604020202020204" pitchFamily="34" charset="0"/>
               </a:rPr>
+              <a:t>dominance is expected. As the primary municipal body, it handles the widest range of complaint categories and the highest complaint volume, yet maintains a 70% effective resolution rate. In contrast, </a:t>
+            </a:r>
+            <a:r>
+              <a:rPr lang="en-US" sz="1400" dirty="0">
+                <a:latin typeface="Bahnschrift Light" panose="020B0502040204020203" pitchFamily="34" charset="0"/>
+                <a:ea typeface="Microsoft Sans Serif" panose="020B0604020202020204" pitchFamily="34" charset="0"/>
+                <a:cs typeface="Microsoft Sans Serif" panose="020B0604020202020204" pitchFamily="34" charset="0"/>
+              </a:rPr>
+              <a:t>BTC </a:t>
+            </a:r>
+            <a:r>
+              <a:rPr lang="en-US" sz="1400" dirty="0">
+                <a:solidFill>
+                  <a:schemeClr val="bg2">
+                    <a:lumMod val="50000"/>
+                  </a:schemeClr>
+                </a:solidFill>
+                <a:latin typeface="Bahnschrift Light" panose="020B0502040204020203" pitchFamily="34" charset="0"/>
+                <a:ea typeface="Microsoft Sans Serif" panose="020B0604020202020204" pitchFamily="34" charset="0"/>
+                <a:cs typeface="Microsoft Sans Serif" panose="020B0604020202020204" pitchFamily="34" charset="0"/>
+              </a:rPr>
+              <a:t>has a </a:t>
+            </a:r>
+            <a:r>
+              <a:rPr lang="en-US" sz="1400" dirty="0">
+                <a:solidFill>
+                  <a:schemeClr val="bg1">
+                    <a:lumMod val="50000"/>
+                  </a:schemeClr>
+                </a:solidFill>
+                <a:latin typeface="Bahnschrift Light" panose="020B0502040204020203" pitchFamily="34" charset="0"/>
+                <a:ea typeface="Microsoft Sans Serif" panose="020B0604020202020204" pitchFamily="34" charset="0"/>
+                <a:cs typeface="Microsoft Sans Serif" panose="020B0604020202020204" pitchFamily="34" charset="0"/>
+              </a:rPr>
               <a:t>36% effective resolution. But it is primarily driven by parking-related sub categories whose evidence-verification requirements and time-sensitive nature may plausibly contribute to the observed contrast</a:t>
             </a:r>
           </a:p>
@@ -6894,7 +7014,7 @@
         </p:nvSpPr>
         <p:spPr>
           <a:xfrm>
-            <a:off x="7175648" y="5229844"/>
+            <a:off x="7175648" y="5370551"/>
             <a:ext cx="4691671" cy="553998"/>
           </a:xfrm>
           <a:prstGeom prst="rect">
@@ -6978,7 +7098,7 @@
         </p:nvSpPr>
         <p:spPr>
           <a:xfrm>
-            <a:off x="3348406" y="6213540"/>
+            <a:off x="2812461" y="6214666"/>
             <a:ext cx="6786136" cy="261610"/>
           </a:xfrm>
           <a:prstGeom prst="rect">
@@ -7163,7 +7283,7 @@
         <p:spPr>
           <a:xfrm>
             <a:off x="2595809" y="3260206"/>
-            <a:ext cx="6805799" cy="1172817"/>
+            <a:ext cx="7252279" cy="1172817"/>
           </a:xfrm>
           <a:prstGeom prst="roundRect">
             <a:avLst>
@@ -7570,7 +7690,7 @@
         <p:spPr>
           <a:xfrm>
             <a:off x="2931818" y="3348723"/>
-            <a:ext cx="6469791" cy="954107"/>
+            <a:ext cx="6805799" cy="954107"/>
           </a:xfrm>
           <a:prstGeom prst="rect">
             <a:avLst/>
@@ -7612,7 +7732,7 @@
                 <a:ea typeface="Microsoft Sans Serif" panose="020B0604020202020204" pitchFamily="34" charset="0"/>
                 <a:cs typeface="Microsoft Sans Serif" panose="020B0604020202020204" pitchFamily="34" charset="0"/>
               </a:rPr>
-              <a:t> with most complaints and impressive effective resolution proves scale isn’t the enemy, but process is. However, it has a relatively higher CPC. As a resident you might have to follow up the complaint to get it solved and the administrators can improve solving complaints at the first instance.</a:t>
+              <a:t> with most complaints and impressive effective resolution proves scale isn’t the enemy, but process is. However, it has a relatively higher comments per complaint. As a resident you might have to follow up the complaint to get it solved and the administrators can improve solving complaints at the first instance.</a:t>
             </a:r>
           </a:p>
         </p:txBody>
@@ -7716,7 +7836,7 @@
                 </a:solidFill>
                 <a:latin typeface="Bahnschrift SemiBold Condensed" panose="020B0502040204020203" pitchFamily="34" charset="0"/>
               </a:rPr>
-              <a:t>Yes! – more than you category</a:t>
+              <a:t>Yes! more than your category</a:t>
             </a:r>
           </a:p>
         </p:txBody>
@@ -7958,7 +8078,7 @@
         </p:nvSpPr>
         <p:spPr>
           <a:xfrm rot="5400000">
-            <a:off x="7300052" y="2806976"/>
+            <a:off x="7314438" y="2596551"/>
             <a:ext cx="4934047" cy="3168000"/>
           </a:xfrm>
           <a:prstGeom prst="roundRect">
@@ -8023,7 +8143,7 @@
         </p:nvSpPr>
         <p:spPr>
           <a:xfrm rot="5400000">
-            <a:off x="-4461" y="2806977"/>
+            <a:off x="-9022" y="2596552"/>
             <a:ext cx="4934046" cy="3168000"/>
           </a:xfrm>
           <a:prstGeom prst="roundRect">
@@ -8212,7 +8332,7 @@
         </p:blipFill>
         <p:spPr>
           <a:xfrm>
-            <a:off x="1016912" y="1692711"/>
+            <a:off x="1012351" y="1482286"/>
             <a:ext cx="2901600" cy="2299105"/>
           </a:xfrm>
           <a:prstGeom prst="rect">
@@ -8276,7 +8396,7 @@
         </p:nvSpPr>
         <p:spPr>
           <a:xfrm>
-            <a:off x="968513" y="4140278"/>
+            <a:off x="963952" y="3929853"/>
             <a:ext cx="2848597" cy="1169551"/>
           </a:xfrm>
           <a:prstGeom prst="rect">
@@ -8364,7 +8484,7 @@
         </p:nvSpPr>
         <p:spPr>
           <a:xfrm>
-            <a:off x="957701" y="5420492"/>
+            <a:off x="953140" y="5210067"/>
             <a:ext cx="2848597" cy="954107"/>
           </a:xfrm>
           <a:prstGeom prst="rect">
@@ -8437,7 +8557,7 @@
         </p:blipFill>
         <p:spPr>
           <a:xfrm>
-            <a:off x="8298738" y="1692711"/>
+            <a:off x="8313124" y="1482286"/>
             <a:ext cx="2901600" cy="2299105"/>
           </a:xfrm>
           <a:prstGeom prst="rect">
@@ -8606,8 +8726,8 @@
         </p:nvSpPr>
         <p:spPr>
           <a:xfrm>
-            <a:off x="8280450" y="4125903"/>
-            <a:ext cx="2973252" cy="954107"/>
+            <a:off x="8294836" y="3915478"/>
+            <a:ext cx="2973252" cy="738664"/>
           </a:xfrm>
           <a:prstGeom prst="rect">
             <a:avLst/>
@@ -8636,7 +8756,7 @@
                 <a:ea typeface="Microsoft Sans Serif" panose="020B0604020202020204" pitchFamily="34" charset="0"/>
                 <a:cs typeface="Microsoft Sans Serif" panose="020B0604020202020204" pitchFamily="34" charset="0"/>
               </a:rPr>
-              <a:t>Two of its relevant sub categories having ignorance rates of 50% and 60% are parking related</a:t>
+              <a:t>Two of its sub categories having ignorance rates of 50% and 60% are parking related</a:t>
             </a:r>
           </a:p>
         </p:txBody>
@@ -8655,7 +8775,7 @@
         </p:nvSpPr>
         <p:spPr>
           <a:xfrm>
-            <a:off x="8280450" y="5176604"/>
+            <a:off x="8294836" y="4647391"/>
             <a:ext cx="2973252" cy="1384995"/>
           </a:xfrm>
           <a:prstGeom prst="rect">
@@ -8698,6 +8818,55 @@
               <a:ea typeface="Microsoft Sans Serif" panose="020B0604020202020204" pitchFamily="34" charset="0"/>
               <a:cs typeface="Microsoft Sans Serif" panose="020B0604020202020204" pitchFamily="34" charset="0"/>
             </a:endParaRPr>
+          </a:p>
+        </p:txBody>
+      </p:sp>
+      <p:sp>
+        <p:nvSpPr>
+          <p:cNvPr id="6" name="TextBox 5">
+            <a:extLst>
+              <a:ext uri="{FF2B5EF4-FFF2-40B4-BE49-F238E27FC236}">
+                <a16:creationId xmlns:a16="http://schemas.microsoft.com/office/drawing/2014/main" id="{C7C40172-34CA-EEC6-6397-37E4CC45BA63}"/>
+              </a:ext>
+            </a:extLst>
+          </p:cNvPr>
+          <p:cNvSpPr txBox="1"/>
+          <p:nvPr/>
+        </p:nvSpPr>
+        <p:spPr>
+          <a:xfrm>
+            <a:off x="8294836" y="6045233"/>
+            <a:ext cx="2973252" cy="523220"/>
+          </a:xfrm>
+          <a:prstGeom prst="rect">
+            <a:avLst/>
+          </a:prstGeom>
+          <a:noFill/>
+        </p:spPr>
+        <p:txBody>
+          <a:bodyPr wrap="square" rtlCol="0">
+            <a:spAutoFit/>
+          </a:bodyPr>
+          <a:lstStyle/>
+          <a:p>
+            <a:pPr marL="285750" indent="-285750">
+              <a:buFont typeface="Arial" panose="020B0604020202020204" pitchFamily="34" charset="0"/>
+              <a:buChar char="•"/>
+            </a:pPr>
+            <a:r>
+              <a:rPr lang="en-IN" sz="1400" dirty="0">
+                <a:solidFill>
+                  <a:schemeClr val="tx1">
+                    <a:lumMod val="75000"/>
+                    <a:lumOff val="25000"/>
+                  </a:schemeClr>
+                </a:solidFill>
+                <a:latin typeface="Bahnschrift Light" panose="020B0502040204020203" pitchFamily="34" charset="0"/>
+                <a:ea typeface="Microsoft Sans Serif" panose="020B0604020202020204" pitchFamily="34" charset="0"/>
+                <a:cs typeface="Microsoft Sans Serif" panose="020B0604020202020204" pitchFamily="34" charset="0"/>
+              </a:rPr>
+              <a:t>And the only category under BTC, hence the exact metrics.</a:t>
+            </a:r>
           </a:p>
         </p:txBody>
       </p:sp>

</xml_diff>

<commit_message>
changed the embedded linked url in the ppt
</commit_message>
<xml_diff>
--- a/Complaint_Log_Analysis_Slides.pptx
+++ b/Complaint_Log_Analysis_Slides.pptx
@@ -1587,7 +1587,7 @@
           <a:p>
             <a:fld id="{0E044B61-B5F1-4E54-8FE3-9F387B431724}" type="datetimeFigureOut">
               <a:rPr lang="en-IN" smtClean="0"/>
-              <a:t>30-06-2026</a:t>
+              <a:t>29-07-2026</a:t>
             </a:fld>
             <a:endParaRPr lang="en-IN"/>
           </a:p>
@@ -1787,7 +1787,7 @@
           <a:p>
             <a:fld id="{0E044B61-B5F1-4E54-8FE3-9F387B431724}" type="datetimeFigureOut">
               <a:rPr lang="en-IN" smtClean="0"/>
-              <a:t>30-06-2026</a:t>
+              <a:t>29-07-2026</a:t>
             </a:fld>
             <a:endParaRPr lang="en-IN"/>
           </a:p>
@@ -1997,7 +1997,7 @@
           <a:p>
             <a:fld id="{0E044B61-B5F1-4E54-8FE3-9F387B431724}" type="datetimeFigureOut">
               <a:rPr lang="en-IN" smtClean="0"/>
-              <a:t>30-06-2026</a:t>
+              <a:t>29-07-2026</a:t>
             </a:fld>
             <a:endParaRPr lang="en-IN"/>
           </a:p>
@@ -2197,7 +2197,7 @@
           <a:p>
             <a:fld id="{0E044B61-B5F1-4E54-8FE3-9F387B431724}" type="datetimeFigureOut">
               <a:rPr lang="en-IN" smtClean="0"/>
-              <a:t>30-06-2026</a:t>
+              <a:t>29-07-2026</a:t>
             </a:fld>
             <a:endParaRPr lang="en-IN"/>
           </a:p>
@@ -2473,7 +2473,7 @@
           <a:p>
             <a:fld id="{0E044B61-B5F1-4E54-8FE3-9F387B431724}" type="datetimeFigureOut">
               <a:rPr lang="en-IN" smtClean="0"/>
-              <a:t>30-06-2026</a:t>
+              <a:t>29-07-2026</a:t>
             </a:fld>
             <a:endParaRPr lang="en-IN"/>
           </a:p>
@@ -2741,7 +2741,7 @@
           <a:p>
             <a:fld id="{0E044B61-B5F1-4E54-8FE3-9F387B431724}" type="datetimeFigureOut">
               <a:rPr lang="en-IN" smtClean="0"/>
-              <a:t>30-06-2026</a:t>
+              <a:t>29-07-2026</a:t>
             </a:fld>
             <a:endParaRPr lang="en-IN"/>
           </a:p>
@@ -3156,7 +3156,7 @@
           <a:p>
             <a:fld id="{0E044B61-B5F1-4E54-8FE3-9F387B431724}" type="datetimeFigureOut">
               <a:rPr lang="en-IN" smtClean="0"/>
-              <a:t>30-06-2026</a:t>
+              <a:t>29-07-2026</a:t>
             </a:fld>
             <a:endParaRPr lang="en-IN"/>
           </a:p>
@@ -3298,7 +3298,7 @@
           <a:p>
             <a:fld id="{0E044B61-B5F1-4E54-8FE3-9F387B431724}" type="datetimeFigureOut">
               <a:rPr lang="en-IN" smtClean="0"/>
-              <a:t>30-06-2026</a:t>
+              <a:t>29-07-2026</a:t>
             </a:fld>
             <a:endParaRPr lang="en-IN"/>
           </a:p>
@@ -3411,7 +3411,7 @@
           <a:p>
             <a:fld id="{0E044B61-B5F1-4E54-8FE3-9F387B431724}" type="datetimeFigureOut">
               <a:rPr lang="en-IN" smtClean="0"/>
-              <a:t>30-06-2026</a:t>
+              <a:t>29-07-2026</a:t>
             </a:fld>
             <a:endParaRPr lang="en-IN"/>
           </a:p>
@@ -3724,7 +3724,7 @@
           <a:p>
             <a:fld id="{0E044B61-B5F1-4E54-8FE3-9F387B431724}" type="datetimeFigureOut">
               <a:rPr lang="en-IN" smtClean="0"/>
-              <a:t>30-06-2026</a:t>
+              <a:t>29-07-2026</a:t>
             </a:fld>
             <a:endParaRPr lang="en-IN"/>
           </a:p>
@@ -4013,7 +4013,7 @@
           <a:p>
             <a:fld id="{0E044B61-B5F1-4E54-8FE3-9F387B431724}" type="datetimeFigureOut">
               <a:rPr lang="en-IN" smtClean="0"/>
-              <a:t>30-06-2026</a:t>
+              <a:t>29-07-2026</a:t>
             </a:fld>
             <a:endParaRPr lang="en-IN"/>
           </a:p>
@@ -4256,7 +4256,7 @@
           <a:p>
             <a:fld id="{0E044B61-B5F1-4E54-8FE3-9F387B431724}" type="datetimeFigureOut">
               <a:rPr lang="en-IN" smtClean="0"/>
-              <a:t>30-06-2026</a:t>
+              <a:t>29-07-2026</a:t>
             </a:fld>
             <a:endParaRPr lang="en-IN"/>
           </a:p>
@@ -9239,14 +9239,21 @@
             <a:r>
               <a:rPr lang="en-US" sz="1400" dirty="0">
                 <a:solidFill>
-                  <a:schemeClr val="bg1">
+                  <a:schemeClr val="tx1">
                     <a:lumMod val="50000"/>
+                    <a:lumOff val="50000"/>
                   </a:schemeClr>
                 </a:solidFill>
                 <a:latin typeface="+mj-lt"/>
                 <a:ea typeface="Calibri Light" panose="020F0302020204030204" pitchFamily="34" charset="0"/>
                 <a:cs typeface="Calibri Light" panose="020F0302020204030204" pitchFamily="34" charset="0"/>
-                <a:hlinkClick r:id="rId3"/>
+                <a:hlinkClick r:id="rId3">
+                  <a:extLst>
+                    <a:ext uri="{A12FA001-AC4F-418D-AE19-62706E023703}">
+                      <ahyp:hlinkClr xmlns:ahyp="http://schemas.microsoft.com/office/drawing/2018/hyperlinkcolor" val="tx"/>
+                    </a:ext>
+                  </a:extLst>
+                </a:hlinkClick>
               </a:rPr>
               <a:t>LinkedIn</a:t>
             </a:r>

</xml_diff>